<commit_message>
Seasonal Agriculture Performance Analysis: code, presentation and dataset
</commit_message>
<xml_diff>
--- a/Seasonal_Agriculture_Analysis_Presentation.pptx
+++ b/Seasonal_Agriculture_Analysis_Presentation.pptx
@@ -134,7 +134,7 @@
             <a:srgbClr val="A4A3A4"/>
           </p15:clr>
         </p15:guide>
-        <p15:guide id="2" pos="408" userDrawn="1">
+        <p15:guide id="2" pos="426" userDrawn="1">
           <p15:clr>
             <a:srgbClr val="A4A3A4"/>
           </p15:clr>
@@ -21708,7 +21708,7 @@
         </p:nvSpPr>
         <p:spPr>
           <a:xfrm>
-            <a:off x="457200" y="1371600"/>
+            <a:off x="293370" y="819150"/>
             <a:ext cx="4389120" cy="4389120"/>
           </a:xfrm>
           <a:prstGeom prst="rect">
@@ -22827,13 +22827,17 @@
           </p:nvPr>
         </p:nvSpPr>
         <p:spPr>
+          <a:xfrm>
+            <a:off x="0" y="-77470"/>
+            <a:ext cx="11370945" cy="6549390"/>
+          </a:xfrm>
           <a:prstGeom prst="rect">
             <a:avLst/>
           </a:prstGeom>
         </p:spPr>
         <p:txBody>
           <a:bodyPr anchor="ctr">
-            <a:normAutofit fontScale="90000"/>
+            <a:normAutofit/>
           </a:bodyPr>
           <a:lstStyle/>
           <a:p>
@@ -22844,30 +22848,6 @@
               <a:t>THANK YOU</a:t>
             </a:r>
           </a:p>
-        </p:txBody>
-      </p:sp>
-      <p:sp>
-        <p:nvSpPr>
-          <p:cNvPr id="31" name="Text Placeholder 30"/>
-          <p:cNvSpPr>
-            <a:spLocks noGrp="1"/>
-          </p:cNvSpPr>
-          <p:nvPr>
-            <p:ph type="body" sz="quarter" idx="13"/>
-          </p:nvPr>
-        </p:nvSpPr>
-        <p:spPr>
-          <a:xfrm>
-            <a:off x="3727865" y="4641925"/>
-            <a:ext cx="2139695" cy="1108635"/>
-          </a:xfrm>
-        </p:spPr>
-        <p:txBody>
-          <a:bodyPr>
-            <a:normAutofit/>
-          </a:bodyPr>
-          <a:lstStyle/>
-          <a:p/>
         </p:txBody>
       </p:sp>
       <p:sp>
@@ -24133,105 +24113,6 @@
           </a:prstGeom>
         </p:spPr>
       </p:pic>
-      <p:sp>
-        <p:nvSpPr>
-          <p:cNvPr id="12" name="Text Placeholder 11"/>
-          <p:cNvSpPr>
-            <a:spLocks noGrp="1"/>
-          </p:cNvSpPr>
-          <p:nvPr>
-            <p:ph type="body" sz="quarter" idx="12"/>
-          </p:nvPr>
-        </p:nvSpPr>
-        <p:spPr>
-          <a:xfrm>
-            <a:off x="2975013" y="3962573"/>
-            <a:ext cx="2139696" cy="344312"/>
-          </a:xfrm>
-        </p:spPr>
-        <p:txBody>
-          <a:bodyPr>
-            <a:normAutofit fontScale="92500" lnSpcReduction="20000"/>
-          </a:bodyPr>
-          <a:lstStyle/>
-          <a:p>
-            <a:endParaRPr lang="en-IN" dirty="0"/>
-          </a:p>
-        </p:txBody>
-      </p:sp>
-      <p:sp>
-        <p:nvSpPr>
-          <p:cNvPr id="46" name="TextBox 45"/>
-          <p:cNvSpPr txBox="1"/>
-          <p:nvPr/>
-        </p:nvSpPr>
-        <p:spPr>
-          <a:xfrm>
-            <a:off x="1371600" y="2926080"/>
-            <a:ext cx="8412480" cy="2286000"/>
-          </a:xfrm>
-          <a:prstGeom prst="rect">
-            <a:avLst/>
-          </a:prstGeom>
-          <a:noFill/>
-        </p:spPr>
-        <p:txBody>
-          <a:bodyPr wrap="square">
-            <a:spAutoFit/>
-          </a:bodyPr>
-          <a:lstStyle/>
-          <a:p>
-            <a:pPr algn="ctr">
-              <a:spcAft>
-                <a:spcPts val="1000"/>
-              </a:spcAft>
-              <a:defRPr sz="2000" b="1">
-                <a:solidFill>
-                  <a:srgbClr val="1A5276"/>
-                </a:solidFill>
-              </a:defRPr>
-            </a:pPr>
-            <a:r>
-              <a:t>Seasonal Agriculture Performance Analysis</a:t>
-            </a:r>
-          </a:p>
-          <a:p>
-            <a:pPr algn="ctr">
-              <a:spcAft>
-                <a:spcPts val="1000"/>
-              </a:spcAft>
-              <a:defRPr sz="1500" b="1">
-                <a:solidFill>
-                  <a:srgbClr val="27AE60"/>
-                </a:solidFill>
-              </a:defRPr>
-            </a:pPr>
-            <a:r>
-              <a:t>Siddhi Ramkrishna Manjarekar  |  STU ID: STU654e5442c94401699632194</a:t>
-            </a:r>
-            <a:br/>
-            <a:r>
-              <a:t>Sir Parashurambhau College, Pune</a:t>
-            </a:r>
-          </a:p>
-          <a:p>
-            <a:pPr algn="ctr">
-              <a:defRPr sz="1300">
-                <a:solidFill>
-                  <a:srgbClr val="555555"/>
-                </a:solidFill>
-              </a:defRPr>
-            </a:pPr>
-            <a:r>
-              <a:t>VOIS AICTE Data Analytics Internship (Batch 1 / August Batch 2026)</a:t>
-            </a:r>
-            <a:br/>
-            <a:r>
-              <a:t>Edunet Foundation  •  Vodafone Idea Foundation  •  AICTE</a:t>
-            </a:r>
-          </a:p>
-        </p:txBody>
-      </p:sp>
     </p:spTree>
   </p:cSld>
   <p:clrMapOvr>
@@ -24438,10 +24319,15 @@
                             </p:stCondLst>
                             <p:childTnLst>
                               <p:par>
-                                <p:cTn id="18" presetID="12" presetClass="entr" presetSubtype="4" fill="hold" grpId="0" nodeType="clickEffect">
+                                <p:cTn id="18" presetID="12" presetClass="entr" presetSubtype="4" fill="hold" grpId="0" nodeType="clickEffect" nodePh="1">
                                   <p:stCondLst>
                                     <p:cond delay="0"/>
                                   </p:stCondLst>
+                                  <p:endCondLst>
+                                    <p:cond evt="begin" delay="0">
+                                      <p:tn val="18"/>
+                                    </p:cond>
+                                  </p:endCondLst>
                                   <p:childTnLst>
                                     <p:set>
                                       <p:cBhvr>
@@ -24451,11 +24337,7 @@
                                           </p:stCondLst>
                                         </p:cTn>
                                         <p:tgtEl>
-                                          <p:spTgt spid="31">
-                                            <p:txEl>
-                                              <p:pRg st="0" end="0"/>
-                                            </p:txEl>
-                                          </p:spTgt>
+                                          <p:spTgt spid="20"/>
                                         </p:tgtEl>
                                         <p:attrNameLst>
                                           <p:attrName>style.visibility</p:attrName>
@@ -24469,11 +24351,7 @@
                                       <p:cBhvr additive="base">
                                         <p:cTn id="20" dur="500"/>
                                         <p:tgtEl>
-                                          <p:spTgt spid="31">
-                                            <p:txEl>
-                                              <p:pRg st="0" end="0"/>
-                                            </p:txEl>
-                                          </p:spTgt>
+                                          <p:spTgt spid="20"/>
                                         </p:tgtEl>
                                         <p:attrNameLst>
                                           <p:attrName>ppt_y</p:attrName>
@@ -24496,11 +24374,7 @@
                                       <p:cBhvr>
                                         <p:cTn id="21" dur="500"/>
                                         <p:tgtEl>
-                                          <p:spTgt spid="31">
-                                            <p:txEl>
-                                              <p:pRg st="0" end="0"/>
-                                            </p:txEl>
-                                          </p:spTgt>
+                                          <p:spTgt spid="20"/>
                                         </p:tgtEl>
                                       </p:cBhvr>
                                     </p:animEffect>
@@ -24544,7 +24418,7 @@
                                           </p:stCondLst>
                                         </p:cTn>
                                         <p:tgtEl>
-                                          <p:spTgt spid="20"/>
+                                          <p:spTgt spid="30"/>
                                         </p:tgtEl>
                                         <p:attrNameLst>
                                           <p:attrName>style.visibility</p:attrName>
@@ -24558,7 +24432,7 @@
                                       <p:cBhvr additive="base">
                                         <p:cTn id="26" dur="500"/>
                                         <p:tgtEl>
-                                          <p:spTgt spid="20"/>
+                                          <p:spTgt spid="30"/>
                                         </p:tgtEl>
                                         <p:attrNameLst>
                                           <p:attrName>ppt_y</p:attrName>
@@ -24581,7 +24455,7 @@
                                       <p:cBhvr>
                                         <p:cTn id="27" dur="500"/>
                                         <p:tgtEl>
-                                          <p:spTgt spid="20"/>
+                                          <p:spTgt spid="30"/>
                                         </p:tgtEl>
                                       </p:cBhvr>
                                     </p:animEffect>
@@ -24625,7 +24499,7 @@
                                           </p:stCondLst>
                                         </p:cTn>
                                         <p:tgtEl>
-                                          <p:spTgt spid="30"/>
+                                          <p:spTgt spid="23"/>
                                         </p:tgtEl>
                                         <p:attrNameLst>
                                           <p:attrName>style.visibility</p:attrName>
@@ -24639,7 +24513,7 @@
                                       <p:cBhvr additive="base">
                                         <p:cTn id="32" dur="500"/>
                                         <p:tgtEl>
-                                          <p:spTgt spid="30"/>
+                                          <p:spTgt spid="23"/>
                                         </p:tgtEl>
                                         <p:attrNameLst>
                                           <p:attrName>ppt_y</p:attrName>
@@ -24662,7 +24536,7 @@
                                       <p:cBhvr>
                                         <p:cTn id="33" dur="500"/>
                                         <p:tgtEl>
-                                          <p:spTgt spid="30"/>
+                                          <p:spTgt spid="23"/>
                                         </p:tgtEl>
                                       </p:cBhvr>
                                     </p:animEffect>
@@ -24688,95 +24562,14 @@
                             </p:stCondLst>
                             <p:childTnLst>
                               <p:par>
-                                <p:cTn id="36" presetID="12" presetClass="entr" presetSubtype="4" fill="hold" grpId="0" nodeType="clickEffect" nodePh="1">
-                                  <p:stCondLst>
-                                    <p:cond delay="0"/>
-                                  </p:stCondLst>
-                                  <p:endCondLst>
-                                    <p:cond evt="begin" delay="0">
-                                      <p:tn val="36"/>
-                                    </p:cond>
-                                  </p:endCondLst>
-                                  <p:childTnLst>
-                                    <p:set>
-                                      <p:cBhvr>
-                                        <p:cTn id="37" dur="1" fill="hold">
-                                          <p:stCondLst>
-                                            <p:cond delay="0"/>
-                                          </p:stCondLst>
-                                        </p:cTn>
-                                        <p:tgtEl>
-                                          <p:spTgt spid="23"/>
-                                        </p:tgtEl>
-                                        <p:attrNameLst>
-                                          <p:attrName>style.visibility</p:attrName>
-                                        </p:attrNameLst>
-                                      </p:cBhvr>
-                                      <p:to>
-                                        <p:strVal val="visible"/>
-                                      </p:to>
-                                    </p:set>
-                                    <p:anim calcmode="lin" valueType="num">
-                                      <p:cBhvr additive="base">
-                                        <p:cTn id="38" dur="500"/>
-                                        <p:tgtEl>
-                                          <p:spTgt spid="23"/>
-                                        </p:tgtEl>
-                                        <p:attrNameLst>
-                                          <p:attrName>ppt_y</p:attrName>
-                                        </p:attrNameLst>
-                                      </p:cBhvr>
-                                      <p:tavLst>
-                                        <p:tav tm="0">
-                                          <p:val>
-                                            <p:strVal val="#ppt_y+#ppt_h*1.125000"/>
-                                          </p:val>
-                                        </p:tav>
-                                        <p:tav tm="100000">
-                                          <p:val>
-                                            <p:strVal val="#ppt_y"/>
-                                          </p:val>
-                                        </p:tav>
-                                      </p:tavLst>
-                                    </p:anim>
-                                    <p:animEffect transition="in" filter="wipe(up)">
-                                      <p:cBhvr>
-                                        <p:cTn id="39" dur="500"/>
-                                        <p:tgtEl>
-                                          <p:spTgt spid="23"/>
-                                        </p:tgtEl>
-                                      </p:cBhvr>
-                                    </p:animEffect>
-                                  </p:childTnLst>
-                                </p:cTn>
-                              </p:par>
-                            </p:childTnLst>
-                          </p:cTn>
-                        </p:par>
-                      </p:childTnLst>
-                    </p:cTn>
-                  </p:par>
-                  <p:par>
-                    <p:cTn id="40" fill="hold">
-                      <p:stCondLst>
-                        <p:cond delay="indefinite"/>
-                      </p:stCondLst>
-                      <p:childTnLst>
-                        <p:par>
-                          <p:cTn id="41" fill="hold">
-                            <p:stCondLst>
-                              <p:cond delay="0"/>
-                            </p:stCondLst>
-                            <p:childTnLst>
-                              <p:par>
-                                <p:cTn id="42" presetID="12" presetClass="entr" presetSubtype="4" fill="hold" grpId="0" nodeType="clickEffect">
+                                <p:cTn id="36" presetID="12" presetClass="entr" presetSubtype="4" fill="hold" grpId="0" nodeType="clickEffect">
                                   <p:stCondLst>
                                     <p:cond delay="0"/>
                                   </p:stCondLst>
                                   <p:childTnLst>
                                     <p:set>
                                       <p:cBhvr>
-                                        <p:cTn id="43" dur="1" fill="hold">
+                                        <p:cTn id="37" dur="1" fill="hold">
                                           <p:stCondLst>
                                             <p:cond delay="0"/>
                                           </p:stCondLst>
@@ -24794,7 +24587,7 @@
                                     </p:set>
                                     <p:anim calcmode="lin" valueType="num">
                                       <p:cBhvr additive="base">
-                                        <p:cTn id="44" dur="500"/>
+                                        <p:cTn id="38" dur="500"/>
                                         <p:tgtEl>
                                           <p:spTgt spid="32"/>
                                         </p:tgtEl>
@@ -24817,7 +24610,7 @@
                                     </p:anim>
                                     <p:animEffect transition="in" filter="wipe(up)">
                                       <p:cBhvr>
-                                        <p:cTn id="45" dur="500"/>
+                                        <p:cTn id="39" dur="500"/>
                                         <p:tgtEl>
                                           <p:spTgt spid="32"/>
                                         </p:tgtEl>
@@ -24855,7 +24648,6 @@
     </p:tnLst>
     <p:bldLst>
       <p:bldP spid="3" grpId="0"/>
-      <p:bldP spid="31" grpId="0" build="p"/>
       <p:bldP spid="17" grpId="0"/>
       <p:bldP spid="20" grpId="0"/>
       <p:bldP spid="23" grpId="0"/>

</xml_diff>